<commit_message>
Arreclat amb Feedback Jorge
</commit_message>
<xml_diff>
--- a/ENTREGA FINAL/4. Diagramas de secuencia/Martí Pagès.pptx
+++ b/ENTREGA FINAL/4. Diagramas de secuencia/Martí Pagès.pptx
@@ -7075,7 +7075,7 @@
           <a:lstStyle/>
           <a:p>
             <a:pPr algn="just"/>
-            <a:endParaRPr lang="ca-ES" dirty="0"/>
+            <a:endParaRPr lang="ca-ES"/>
           </a:p>
           <a:p>
             <a:pPr algn="just"/>
@@ -7085,10 +7085,10 @@
       </p:sp>
       <p:pic>
         <p:nvPicPr>
-          <p:cNvPr id="5" name="Imagen 4">
-            <a:extLst>
-              <a:ext uri="{FF2B5EF4-FFF2-40B4-BE49-F238E27FC236}">
-                <a16:creationId xmlns:a16="http://schemas.microsoft.com/office/drawing/2014/main" id="{EF07597E-31FB-12D3-0A76-6D9D7A194FF8}"/>
+          <p:cNvPr id="3" name="Imagen 2">
+            <a:extLst>
+              <a:ext uri="{FF2B5EF4-FFF2-40B4-BE49-F238E27FC236}">
+                <a16:creationId xmlns:a16="http://schemas.microsoft.com/office/drawing/2014/main" id="{BA49A770-7C04-F771-79F8-F8D630DB73D9}"/>
               </a:ext>
             </a:extLst>
           </p:cNvPr>
@@ -7111,8 +7111,8 @@
         </p:blipFill>
         <p:spPr>
           <a:xfrm>
-            <a:off x="3098245" y="0"/>
-            <a:ext cx="5995509" cy="6858000"/>
+            <a:off x="2969926" y="0"/>
+            <a:ext cx="6252148" cy="6858000"/>
           </a:xfrm>
           <a:prstGeom prst="rect">
             <a:avLst/>
@@ -8013,15 +8013,6 @@
 </file>
 
 <file path=customXml/item1.xml><?xml version="1.0" encoding="utf-8"?>
-<?mso-contentType ?>
-<FormTemplates xmlns="http://schemas.microsoft.com/sharepoint/v3/contenttype/forms">
-  <Display>DocumentLibraryForm</Display>
-  <Edit>DocumentLibraryForm</Edit>
-  <New>DocumentLibraryForm</New>
-</FormTemplates>
-</file>
-
-<file path=customXml/item2.xml><?xml version="1.0" encoding="utf-8"?>
 <ct:contentTypeSchema xmlns:ct="http://schemas.microsoft.com/office/2006/metadata/contentType" xmlns:ma="http://schemas.microsoft.com/office/2006/metadata/properties/metaAttributes" ct:_="" ma:_="" ma:contentTypeName="Documento" ma:contentTypeID="0x01010063BD3DC6F0E81D4FA56575A4B7B24AF5" ma:contentTypeVersion="14" ma:contentTypeDescription="Crear nuevo documento." ma:contentTypeScope="" ma:versionID="ded3d347f3a98b31a82ee0cc093f824b">
   <xsd:schema xmlns:xsd="http://www.w3.org/2001/XMLSchema" xmlns:xs="http://www.w3.org/2001/XMLSchema" xmlns:p="http://schemas.microsoft.com/office/2006/metadata/properties" xmlns:ns3="7b814fa0-4f1b-4d56-8a36-064af1e36e66" xmlns:ns4="b1fa7ccf-aa4f-4f27-84db-07667d020acb" targetNamespace="http://schemas.microsoft.com/office/2006/metadata/properties" ma:root="true" ma:fieldsID="fe3adeea5df1e60fd0d7c7fb86895927" ns3:_="" ns4:_="">
     <xsd:import namespace="7b814fa0-4f1b-4d56-8a36-064af1e36e66"/>
@@ -8250,6 +8241,15 @@
 </ct:contentTypeSchema>
 </file>
 
+<file path=customXml/item2.xml><?xml version="1.0" encoding="utf-8"?>
+<?mso-contentType ?>
+<FormTemplates xmlns="http://schemas.microsoft.com/sharepoint/v3/contenttype/forms">
+  <Display>DocumentLibraryForm</Display>
+  <Edit>DocumentLibraryForm</Edit>
+  <New>DocumentLibraryForm</New>
+</FormTemplates>
+</file>
+
 <file path=customXml/item3.xml><?xml version="1.0" encoding="utf-8"?>
 <p:properties xmlns:p="http://schemas.microsoft.com/office/2006/metadata/properties" xmlns:xsi="http://www.w3.org/2001/XMLSchema-instance" xmlns:pc="http://schemas.microsoft.com/office/infopath/2007/PartnerControls">
   <documentManagement>
@@ -8266,14 +8266,6 @@
 </file>
 
 <file path=customXml/itemProps1.xml><?xml version="1.0" encoding="utf-8"?>
-<ds:datastoreItem xmlns:ds="http://schemas.openxmlformats.org/officeDocument/2006/customXml" ds:itemID="{04171512-FDE1-4E49-B7EA-58AD2B333724}">
-  <ds:schemaRefs>
-    <ds:schemaRef ds:uri="http://schemas.microsoft.com/sharepoint/v3/contenttype/forms"/>
-  </ds:schemaRefs>
-</ds:datastoreItem>
-</file>
-
-<file path=customXml/itemProps2.xml><?xml version="1.0" encoding="utf-8"?>
 <ds:datastoreItem xmlns:ds="http://schemas.openxmlformats.org/officeDocument/2006/customXml" ds:itemID="{E77A2FCE-FB77-4A2D-98B9-B8BD51BEE8CE}">
   <ds:schemaRefs>
     <ds:schemaRef ds:uri="http://schemas.microsoft.com/office/2006/metadata/contentType"/>
@@ -8288,6 +8280,14 @@
     <ds:schemaRef ds:uri="http://purl.org/dc/elements/1.1/"/>
     <ds:schemaRef ds:uri="http://purl.org/dc/terms/"/>
     <ds:schemaRef ds:uri="http://schemas.microsoft.com/internal/obd"/>
+  </ds:schemaRefs>
+</ds:datastoreItem>
+</file>
+
+<file path=customXml/itemProps2.xml><?xml version="1.0" encoding="utf-8"?>
+<ds:datastoreItem xmlns:ds="http://schemas.openxmlformats.org/officeDocument/2006/customXml" ds:itemID="{04171512-FDE1-4E49-B7EA-58AD2B333724}">
+  <ds:schemaRefs>
+    <ds:schemaRef ds:uri="http://schemas.microsoft.com/sharepoint/v3/contenttype/forms"/>
   </ds:schemaRefs>
 </ds:datastoreItem>
 </file>

</xml_diff>

<commit_message>
Fets Diagrames 1 i 2 Martí al DC
</commit_message>
<xml_diff>
--- a/ENTREGA FINAL/4. Diagramas de secuencia/Martí Pagès.pptx
+++ b/ENTREGA FINAL/4. Diagramas de secuencia/Martí Pagès.pptx
@@ -6824,10 +6824,10 @@
       </p:sp>
       <p:pic>
         <p:nvPicPr>
-          <p:cNvPr id="3" name="Imagen 2">
-            <a:extLst>
-              <a:ext uri="{FF2B5EF4-FFF2-40B4-BE49-F238E27FC236}">
-                <a16:creationId xmlns:a16="http://schemas.microsoft.com/office/drawing/2014/main" id="{73344118-DA5E-45C0-E6BE-62BA981FCB43}"/>
+          <p:cNvPr id="5" name="Imagen 4">
+            <a:extLst>
+              <a:ext uri="{FF2B5EF4-FFF2-40B4-BE49-F238E27FC236}">
+                <a16:creationId xmlns:a16="http://schemas.microsoft.com/office/drawing/2014/main" id="{A514A50A-4429-91DD-28B1-E972BBF71802}"/>
               </a:ext>
             </a:extLst>
           </p:cNvPr>
@@ -6850,8 +6850,8 @@
         </p:blipFill>
         <p:spPr>
           <a:xfrm>
-            <a:off x="2092334" y="0"/>
-            <a:ext cx="8007332" cy="6858000"/>
+            <a:off x="2182570" y="0"/>
+            <a:ext cx="7826859" cy="6858000"/>
           </a:xfrm>
           <a:prstGeom prst="rect">
             <a:avLst/>
@@ -8013,6 +8013,15 @@
 </file>
 
 <file path=customXml/item1.xml><?xml version="1.0" encoding="utf-8"?>
+<?mso-contentType ?>
+<FormTemplates xmlns="http://schemas.microsoft.com/sharepoint/v3/contenttype/forms">
+  <Display>DocumentLibraryForm</Display>
+  <Edit>DocumentLibraryForm</Edit>
+  <New>DocumentLibraryForm</New>
+</FormTemplates>
+</file>
+
+<file path=customXml/item2.xml><?xml version="1.0" encoding="utf-8"?>
 <ct:contentTypeSchema xmlns:ct="http://schemas.microsoft.com/office/2006/metadata/contentType" xmlns:ma="http://schemas.microsoft.com/office/2006/metadata/properties/metaAttributes" ct:_="" ma:_="" ma:contentTypeName="Documento" ma:contentTypeID="0x01010063BD3DC6F0E81D4FA56575A4B7B24AF5" ma:contentTypeVersion="14" ma:contentTypeDescription="Crear nuevo documento." ma:contentTypeScope="" ma:versionID="ded3d347f3a98b31a82ee0cc093f824b">
   <xsd:schema xmlns:xsd="http://www.w3.org/2001/XMLSchema" xmlns:xs="http://www.w3.org/2001/XMLSchema" xmlns:p="http://schemas.microsoft.com/office/2006/metadata/properties" xmlns:ns3="7b814fa0-4f1b-4d56-8a36-064af1e36e66" xmlns:ns4="b1fa7ccf-aa4f-4f27-84db-07667d020acb" targetNamespace="http://schemas.microsoft.com/office/2006/metadata/properties" ma:root="true" ma:fieldsID="fe3adeea5df1e60fd0d7c7fb86895927" ns3:_="" ns4:_="">
     <xsd:import namespace="7b814fa0-4f1b-4d56-8a36-064af1e36e66"/>
@@ -8241,15 +8250,6 @@
 </ct:contentTypeSchema>
 </file>
 
-<file path=customXml/item2.xml><?xml version="1.0" encoding="utf-8"?>
-<?mso-contentType ?>
-<FormTemplates xmlns="http://schemas.microsoft.com/sharepoint/v3/contenttype/forms">
-  <Display>DocumentLibraryForm</Display>
-  <Edit>DocumentLibraryForm</Edit>
-  <New>DocumentLibraryForm</New>
-</FormTemplates>
-</file>
-
 <file path=customXml/item3.xml><?xml version="1.0" encoding="utf-8"?>
 <p:properties xmlns:p="http://schemas.microsoft.com/office/2006/metadata/properties" xmlns:xsi="http://www.w3.org/2001/XMLSchema-instance" xmlns:pc="http://schemas.microsoft.com/office/infopath/2007/PartnerControls">
   <documentManagement>
@@ -8266,6 +8266,14 @@
 </file>
 
 <file path=customXml/itemProps1.xml><?xml version="1.0" encoding="utf-8"?>
+<ds:datastoreItem xmlns:ds="http://schemas.openxmlformats.org/officeDocument/2006/customXml" ds:itemID="{04171512-FDE1-4E49-B7EA-58AD2B333724}">
+  <ds:schemaRefs>
+    <ds:schemaRef ds:uri="http://schemas.microsoft.com/sharepoint/v3/contenttype/forms"/>
+  </ds:schemaRefs>
+</ds:datastoreItem>
+</file>
+
+<file path=customXml/itemProps2.xml><?xml version="1.0" encoding="utf-8"?>
 <ds:datastoreItem xmlns:ds="http://schemas.openxmlformats.org/officeDocument/2006/customXml" ds:itemID="{E77A2FCE-FB77-4A2D-98B9-B8BD51BEE8CE}">
   <ds:schemaRefs>
     <ds:schemaRef ds:uri="http://schemas.microsoft.com/office/2006/metadata/contentType"/>
@@ -8280,14 +8288,6 @@
     <ds:schemaRef ds:uri="http://purl.org/dc/elements/1.1/"/>
     <ds:schemaRef ds:uri="http://purl.org/dc/terms/"/>
     <ds:schemaRef ds:uri="http://schemas.microsoft.com/internal/obd"/>
-  </ds:schemaRefs>
-</ds:datastoreItem>
-</file>
-
-<file path=customXml/itemProps2.xml><?xml version="1.0" encoding="utf-8"?>
-<ds:datastoreItem xmlns:ds="http://schemas.openxmlformats.org/officeDocument/2006/customXml" ds:itemID="{04171512-FDE1-4E49-B7EA-58AD2B333724}">
-  <ds:schemaRefs>
-    <ds:schemaRef ds:uri="http://schemas.microsoft.com/sharepoint/v3/contenttype/forms"/>
   </ds:schemaRefs>
 </ds:datastoreItem>
 </file>

</xml_diff>

<commit_message>
Canviat DS 8 (soy tonota :3)
</commit_message>
<xml_diff>
--- a/ENTREGA FINAL/4. Diagramas de secuencia/Martí Pagès.pptx
+++ b/ENTREGA FINAL/4. Diagramas de secuencia/Martí Pagès.pptx
@@ -6425,10 +6425,10 @@
       </p:sp>
       <p:pic>
         <p:nvPicPr>
-          <p:cNvPr id="5" name="Imagen 4">
-            <a:extLst>
-              <a:ext uri="{FF2B5EF4-FFF2-40B4-BE49-F238E27FC236}">
-                <a16:creationId xmlns:a16="http://schemas.microsoft.com/office/drawing/2014/main" id="{8563A1C2-59D5-79D1-4397-67AB9F42B112}"/>
+          <p:cNvPr id="3" name="Imagen 2">
+            <a:extLst>
+              <a:ext uri="{FF2B5EF4-FFF2-40B4-BE49-F238E27FC236}">
+                <a16:creationId xmlns:a16="http://schemas.microsoft.com/office/drawing/2014/main" id="{11C0A582-3161-B108-3D5A-DFE664107ABD}"/>
               </a:ext>
             </a:extLst>
           </p:cNvPr>
@@ -8013,15 +8013,6 @@
 </file>
 
 <file path=customXml/item1.xml><?xml version="1.0" encoding="utf-8"?>
-<?mso-contentType ?>
-<FormTemplates xmlns="http://schemas.microsoft.com/sharepoint/v3/contenttype/forms">
-  <Display>DocumentLibraryForm</Display>
-  <Edit>DocumentLibraryForm</Edit>
-  <New>DocumentLibraryForm</New>
-</FormTemplates>
-</file>
-
-<file path=customXml/item2.xml><?xml version="1.0" encoding="utf-8"?>
 <ct:contentTypeSchema xmlns:ct="http://schemas.microsoft.com/office/2006/metadata/contentType" xmlns:ma="http://schemas.microsoft.com/office/2006/metadata/properties/metaAttributes" ct:_="" ma:_="" ma:contentTypeName="Documento" ma:contentTypeID="0x01010063BD3DC6F0E81D4FA56575A4B7B24AF5" ma:contentTypeVersion="14" ma:contentTypeDescription="Crear nuevo documento." ma:contentTypeScope="" ma:versionID="ded3d347f3a98b31a82ee0cc093f824b">
   <xsd:schema xmlns:xsd="http://www.w3.org/2001/XMLSchema" xmlns:xs="http://www.w3.org/2001/XMLSchema" xmlns:p="http://schemas.microsoft.com/office/2006/metadata/properties" xmlns:ns3="7b814fa0-4f1b-4d56-8a36-064af1e36e66" xmlns:ns4="b1fa7ccf-aa4f-4f27-84db-07667d020acb" targetNamespace="http://schemas.microsoft.com/office/2006/metadata/properties" ma:root="true" ma:fieldsID="fe3adeea5df1e60fd0d7c7fb86895927" ns3:_="" ns4:_="">
     <xsd:import namespace="7b814fa0-4f1b-4d56-8a36-064af1e36e66"/>
@@ -8250,6 +8241,15 @@
 </ct:contentTypeSchema>
 </file>
 
+<file path=customXml/item2.xml><?xml version="1.0" encoding="utf-8"?>
+<?mso-contentType ?>
+<FormTemplates xmlns="http://schemas.microsoft.com/sharepoint/v3/contenttype/forms">
+  <Display>DocumentLibraryForm</Display>
+  <Edit>DocumentLibraryForm</Edit>
+  <New>DocumentLibraryForm</New>
+</FormTemplates>
+</file>
+
 <file path=customXml/item3.xml><?xml version="1.0" encoding="utf-8"?>
 <p:properties xmlns:p="http://schemas.microsoft.com/office/2006/metadata/properties" xmlns:xsi="http://www.w3.org/2001/XMLSchema-instance" xmlns:pc="http://schemas.microsoft.com/office/infopath/2007/PartnerControls">
   <documentManagement>
@@ -8266,14 +8266,6 @@
 </file>
 
 <file path=customXml/itemProps1.xml><?xml version="1.0" encoding="utf-8"?>
-<ds:datastoreItem xmlns:ds="http://schemas.openxmlformats.org/officeDocument/2006/customXml" ds:itemID="{04171512-FDE1-4E49-B7EA-58AD2B333724}">
-  <ds:schemaRefs>
-    <ds:schemaRef ds:uri="http://schemas.microsoft.com/sharepoint/v3/contenttype/forms"/>
-  </ds:schemaRefs>
-</ds:datastoreItem>
-</file>
-
-<file path=customXml/itemProps2.xml><?xml version="1.0" encoding="utf-8"?>
 <ds:datastoreItem xmlns:ds="http://schemas.openxmlformats.org/officeDocument/2006/customXml" ds:itemID="{E77A2FCE-FB77-4A2D-98B9-B8BD51BEE8CE}">
   <ds:schemaRefs>
     <ds:schemaRef ds:uri="http://schemas.microsoft.com/office/2006/metadata/contentType"/>
@@ -8288,6 +8280,14 @@
     <ds:schemaRef ds:uri="http://purl.org/dc/elements/1.1/"/>
     <ds:schemaRef ds:uri="http://purl.org/dc/terms/"/>
     <ds:schemaRef ds:uri="http://schemas.microsoft.com/internal/obd"/>
+  </ds:schemaRefs>
+</ds:datastoreItem>
+</file>
+
+<file path=customXml/itemProps2.xml><?xml version="1.0" encoding="utf-8"?>
+<ds:datastoreItem xmlns:ds="http://schemas.openxmlformats.org/officeDocument/2006/customXml" ds:itemID="{04171512-FDE1-4E49-B7EA-58AD2B333724}">
+  <ds:schemaRefs>
+    <ds:schemaRef ds:uri="http://schemas.microsoft.com/sharepoint/v3/contenttype/forms"/>
   </ds:schemaRefs>
 </ds:datastoreItem>
 </file>

</xml_diff>